<commit_message>
docs: repair publication deck review gaps
</commit_message>
<xml_diff>
--- a/submission/oss-bounty-escrow-pitch-deck.pptx
+++ b/submission/oss-bounty-escrow-pitch-deck.pptx
@@ -2,14 +2,14 @@
 <file path=ppt/presentation.xml><?xml version="1.0" encoding="utf-8"?>
 <p:presentation xmlns:p="http://schemas.openxmlformats.org/presentationml/2006/main">
   <p:sldMasterIdLst>
-    <p:sldMasterId xmlns:r="http://schemas.openxmlformats.org/officeDocument/2006/relationships" id="2147483648" r:id="R716a76494f1a4963"/>
+    <p:sldMasterId xmlns:r="http://schemas.openxmlformats.org/officeDocument/2006/relationships" id="2147483648" r:id="R7c873cf4a0ce4945"/>
   </p:sldMasterIdLst>
   <p:notesMasterIdLst>
-    <p:notesMasterId xmlns:r="http://schemas.openxmlformats.org/officeDocument/2006/relationships" r:id="R133cd514f4e5471a"/>
+    <p:notesMasterId xmlns:r="http://schemas.openxmlformats.org/officeDocument/2006/relationships" r:id="R0b5c97648ba14495"/>
   </p:notesMasterIdLst>
   <p:sldIdLst>
-    <p:sldId xmlns:r="http://schemas.openxmlformats.org/officeDocument/2006/relationships" id="256" r:id="Re6afa01abf074df3"/>
-    <p:sldId xmlns:r="http://schemas.openxmlformats.org/officeDocument/2006/relationships" id="257" r:id="R6d4aa288091c48a5"/>
+    <p:sldId xmlns:r="http://schemas.openxmlformats.org/officeDocument/2006/relationships" id="256" r:id="Rf1d1a90cc9c64060"/>
+    <p:sldId xmlns:r="http://schemas.openxmlformats.org/officeDocument/2006/relationships" id="257" r:id="R2e547e704ba34b1b"/>
   </p:sldIdLst>
   <p:sldSz cx="12192000" cy="6858000"/>
   <p:notesSz cx="6858000" cy="9144000"/>
@@ -456,11 +456,6 @@
               <a:t>- Reviewed workflow documentation: docs/BUSINESS_FLOW_RUNNER.md</a:t>
             </a:r>
           </a:p>
-          <a:p xmlns:a="http://schemas.openxmlformats.org/drawingml/2006/main">
-            <a:r>
-              <a:t>- Approved submission-package design narrative</a:t>
-            </a:r>
-          </a:p>
         </p:txBody>
       </p:sp>
       <p:sp>
@@ -616,7 +611,7 @@
   </p:cSld>
   <p:clrMap bg1="lt1" tx1="dk1" bg2="lt2" tx2="dk2" accent1="accent1" accent2="accent2" accent3="accent3" accent4="accent4" accent5="accent5" accent6="accent6" hlink="hlink" folHlink="folHlink"/>
   <p:sldLayoutIdLst>
-    <p:sldLayoutId xmlns:r="http://schemas.openxmlformats.org/officeDocument/2006/relationships" id="2147483649" r:id="R1a1db27d433045fe"/>
+    <p:sldLayoutId xmlns:r="http://schemas.openxmlformats.org/officeDocument/2006/relationships" id="2147483649" r:id="R807e235a84f44aff"/>
   </p:sldLayoutIdLst>
   <p:txStyles>
     <p:titleStyle>
@@ -1167,7 +1162,7 @@
           <p:cNvPr id="32" name="project-label">
             <a:extLst xmlns:a="http://schemas.openxmlformats.org/drawingml/2006/main">
               <a:ext uri="{FF2B5EF4-FFF2-40B4-BE49-F238E27FC236}">
-                <a16:creationId xmlns:a16="http://schemas.microsoft.com/office/drawing/2014/main" id="{523BFF90-A27B-4BF7-9CCB-7529A89BC148}"/>
+                <a16:creationId xmlns:a16="http://schemas.microsoft.com/office/drawing/2014/main" id="{30D0BDC2-F4A4-4022-8A89-6545903DDFC0}"/>
               </a:ext>
             </a:extLst>
           </p:cNvPr>
@@ -1217,7 +1212,7 @@
           <p:cNvPr id="2" name="headline">
             <a:extLst xmlns:a="http://schemas.openxmlformats.org/drawingml/2006/main">
               <a:ext uri="{FF2B5EF4-FFF2-40B4-BE49-F238E27FC236}">
-                <a16:creationId xmlns:a16="http://schemas.microsoft.com/office/drawing/2014/main" id="{FBA0575B-771E-4E48-AEC7-A271D184B921}"/>
+                <a16:creationId xmlns:a16="http://schemas.microsoft.com/office/drawing/2014/main" id="{A1DBCE64-CB2F-483E-8856-E8579A3965A1}"/>
               </a:ext>
             </a:extLst>
           </p:cNvPr>
@@ -1267,7 +1262,7 @@
           <p:cNvPr id="3" name="proposition">
             <a:extLst xmlns:a="http://schemas.openxmlformats.org/drawingml/2006/main">
               <a:ext uri="{FF2B5EF4-FFF2-40B4-BE49-F238E27FC236}">
-                <a16:creationId xmlns:a16="http://schemas.microsoft.com/office/drawing/2014/main" id="{81D11AA3-8F33-4CED-BBBF-98662F2ECEF0}"/>
+                <a16:creationId xmlns:a16="http://schemas.microsoft.com/office/drawing/2014/main" id="{F3E3D3B1-DC2A-42B0-938E-867E37E099C9}"/>
               </a:ext>
             </a:extLst>
           </p:cNvPr>
@@ -1317,7 +1312,7 @@
           <p:cNvPr id="4" name="flow-line-1">
             <a:extLst xmlns:a="http://schemas.openxmlformats.org/drawingml/2006/main">
               <a:ext uri="{FF2B5EF4-FFF2-40B4-BE49-F238E27FC236}">
-                <a16:creationId xmlns:a16="http://schemas.microsoft.com/office/drawing/2014/main" id="{A69C2787-1E2C-468B-B71B-EAEA9F9BFA38}"/>
+                <a16:creationId xmlns:a16="http://schemas.microsoft.com/office/drawing/2014/main" id="{8CB09C02-DD3C-4392-BE02-F32B37008AA3}"/>
               </a:ext>
             </a:extLst>
           </p:cNvPr>
@@ -1350,7 +1345,7 @@
           <p:cNvPr id="5" name="flow-line-2">
             <a:extLst xmlns:a="http://schemas.openxmlformats.org/drawingml/2006/main">
               <a:ext uri="{FF2B5EF4-FFF2-40B4-BE49-F238E27FC236}">
-                <a16:creationId xmlns:a16="http://schemas.microsoft.com/office/drawing/2014/main" id="{64D09B59-C7FD-4B19-838A-8EF832973C99}"/>
+                <a16:creationId xmlns:a16="http://schemas.microsoft.com/office/drawing/2014/main" id="{A71A64BD-454F-432A-9365-1ED776965AD7}"/>
               </a:ext>
             </a:extLst>
           </p:cNvPr>
@@ -1383,7 +1378,7 @@
           <p:cNvPr id="6" name="flow-line-3">
             <a:extLst xmlns:a="http://schemas.openxmlformats.org/drawingml/2006/main">
               <a:ext uri="{FF2B5EF4-FFF2-40B4-BE49-F238E27FC236}">
-                <a16:creationId xmlns:a16="http://schemas.microsoft.com/office/drawing/2014/main" id="{D4EB6B5F-1264-4F8B-8F17-462813D6D30B}"/>
+                <a16:creationId xmlns:a16="http://schemas.microsoft.com/office/drawing/2014/main" id="{9E1EC2AF-BB02-4E41-8CA4-4AF004E6F0B5}"/>
               </a:ext>
             </a:extLst>
           </p:cNvPr>
@@ -1416,7 +1411,7 @@
           <p:cNvPr id="7" name="flow-line-4">
             <a:extLst xmlns:a="http://schemas.openxmlformats.org/drawingml/2006/main">
               <a:ext uri="{FF2B5EF4-FFF2-40B4-BE49-F238E27FC236}">
-                <a16:creationId xmlns:a16="http://schemas.microsoft.com/office/drawing/2014/main" id="{756357C0-939E-41C7-90EE-ED61216EE9F2}"/>
+                <a16:creationId xmlns:a16="http://schemas.microsoft.com/office/drawing/2014/main" id="{F2D796B1-B5FF-48AB-8CC7-ABD7A40DC7D9}"/>
               </a:ext>
             </a:extLst>
           </p:cNvPr>
@@ -1446,76 +1441,10 @@
       </p:sp>
       <p:sp>
         <p:nvSpPr>
-          <p:cNvPr id="8" name="expiry-stem">
-            <a:extLst xmlns:a="http://schemas.openxmlformats.org/drawingml/2006/main">
-              <a:ext uri="{FF2B5EF4-FFF2-40B4-BE49-F238E27FC236}">
-                <a16:creationId xmlns:a16="http://schemas.microsoft.com/office/drawing/2014/main" id="{EA226F9D-4B08-4660-856E-6ECC3AEA4FE7}"/>
-              </a:ext>
-            </a:extLst>
-          </p:cNvPr>
-          <p:cNvSpPr>
-            <a:spLocks xmlns:a="http://schemas.openxmlformats.org/drawingml/2006/main" noGrp="1"/>
-          </p:cNvSpPr>
-          <p:nvPr/>
-        </p:nvSpPr>
-        <p:spPr>
-          <a:xfrm xmlns:a="http://schemas.openxmlformats.org/drawingml/2006/main">
-            <a:off x="8239125" y="3810000"/>
-            <a:ext cx="38100" cy="628650"/>
-          </a:xfrm>
-          <a:prstGeom xmlns:a="http://schemas.openxmlformats.org/drawingml/2006/main" prst="rect">
-            <a:avLst/>
-          </a:prstGeom>
-          <a:solidFill xmlns:a="http://schemas.openxmlformats.org/drawingml/2006/main">
-            <a:srgbClr val="F5A524"/>
-          </a:solidFill>
-          <a:ln xmlns:a="http://schemas.openxmlformats.org/drawingml/2006/main" w="0">
-            <a:solidFill>
-              <a:srgbClr val="F5A524"/>
-            </a:solidFill>
-            <a:prstDash val="solid"/>
-          </a:ln>
-        </p:spPr>
-      </p:sp>
-      <p:sp>
-        <p:nvSpPr>
-          <p:cNvPr id="9" name="expiry-branch">
-            <a:extLst xmlns:a="http://schemas.openxmlformats.org/drawingml/2006/main">
-              <a:ext uri="{FF2B5EF4-FFF2-40B4-BE49-F238E27FC236}">
-                <a16:creationId xmlns:a16="http://schemas.microsoft.com/office/drawing/2014/main" id="{9358164C-D80D-46BF-A78E-11C6C25BDD82}"/>
-              </a:ext>
-            </a:extLst>
-          </p:cNvPr>
-          <p:cNvSpPr>
-            <a:spLocks xmlns:a="http://schemas.openxmlformats.org/drawingml/2006/main" noGrp="1"/>
-          </p:cNvSpPr>
-          <p:nvPr/>
-        </p:nvSpPr>
-        <p:spPr>
-          <a:xfrm xmlns:a="http://schemas.openxmlformats.org/drawingml/2006/main">
-            <a:off x="8239125" y="4400550"/>
-            <a:ext cx="1371600" cy="38100"/>
-          </a:xfrm>
-          <a:prstGeom xmlns:a="http://schemas.openxmlformats.org/drawingml/2006/main" prst="rect">
-            <a:avLst/>
-          </a:prstGeom>
-          <a:solidFill xmlns:a="http://schemas.openxmlformats.org/drawingml/2006/main">
-            <a:srgbClr val="F5A524"/>
-          </a:solidFill>
-          <a:ln xmlns:a="http://schemas.openxmlformats.org/drawingml/2006/main" w="0">
-            <a:solidFill>
-              <a:srgbClr val="F5A524"/>
-            </a:solidFill>
-            <a:prstDash val="solid"/>
-          </a:ln>
-        </p:spPr>
-      </p:sp>
-      <p:sp>
-        <p:nvSpPr>
-          <p:cNvPr id="10" name="node-01">
-            <a:extLst xmlns:a="http://schemas.openxmlformats.org/drawingml/2006/main">
-              <a:ext uri="{FF2B5EF4-FFF2-40B4-BE49-F238E27FC236}">
-                <a16:creationId xmlns:a16="http://schemas.microsoft.com/office/drawing/2014/main" id="{7389B3B1-1EE4-4014-AF7C-23EF89A0F456}"/>
+          <p:cNvPr id="8" name="node-01">
+            <a:extLst xmlns:a="http://schemas.openxmlformats.org/drawingml/2006/main">
+              <a:ext uri="{FF2B5EF4-FFF2-40B4-BE49-F238E27FC236}">
+                <a16:creationId xmlns:a16="http://schemas.microsoft.com/office/drawing/2014/main" id="{5DD93126-FE21-4B64-9CD5-E4F23E661F0A}"/>
               </a:ext>
             </a:extLst>
           </p:cNvPr>
@@ -1547,10 +1476,10 @@
       </p:sp>
       <p:sp>
         <p:nvSpPr>
-          <p:cNvPr id="11" name="node-index-01">
-            <a:extLst xmlns:a="http://schemas.openxmlformats.org/drawingml/2006/main">
-              <a:ext uri="{FF2B5EF4-FFF2-40B4-BE49-F238E27FC236}">
-                <a16:creationId xmlns:a16="http://schemas.microsoft.com/office/drawing/2014/main" id="{9050CD7B-98C7-4EC9-9605-AF86F4DFF137}"/>
+          <p:cNvPr id="9" name="node-index-01">
+            <a:extLst xmlns:a="http://schemas.openxmlformats.org/drawingml/2006/main">
+              <a:ext uri="{FF2B5EF4-FFF2-40B4-BE49-F238E27FC236}">
+                <a16:creationId xmlns:a16="http://schemas.microsoft.com/office/drawing/2014/main" id="{5FF49BAD-E200-4527-944B-60FE520AAE29}"/>
               </a:ext>
             </a:extLst>
           </p:cNvPr>
@@ -1597,10 +1526,10 @@
       </p:sp>
       <p:sp>
         <p:nvSpPr>
-          <p:cNvPr id="12" name="node-label-01">
-            <a:extLst xmlns:a="http://schemas.openxmlformats.org/drawingml/2006/main">
-              <a:ext uri="{FF2B5EF4-FFF2-40B4-BE49-F238E27FC236}">
-                <a16:creationId xmlns:a16="http://schemas.microsoft.com/office/drawing/2014/main" id="{118A89E1-4854-4730-B582-82D1D9D249E2}"/>
+          <p:cNvPr id="10" name="node-label-01">
+            <a:extLst xmlns:a="http://schemas.openxmlformats.org/drawingml/2006/main">
+              <a:ext uri="{FF2B5EF4-FFF2-40B4-BE49-F238E27FC236}">
+                <a16:creationId xmlns:a16="http://schemas.microsoft.com/office/drawing/2014/main" id="{D2198E3B-B084-414D-8B6C-981DBC33BA3E}"/>
               </a:ext>
             </a:extLst>
           </p:cNvPr>
@@ -1647,10 +1576,10 @@
       </p:sp>
       <p:sp>
         <p:nvSpPr>
-          <p:cNvPr id="13" name="node-02">
-            <a:extLst xmlns:a="http://schemas.openxmlformats.org/drawingml/2006/main">
-              <a:ext uri="{FF2B5EF4-FFF2-40B4-BE49-F238E27FC236}">
-                <a16:creationId xmlns:a16="http://schemas.microsoft.com/office/drawing/2014/main" id="{BA92DC5E-85E1-44EE-BC24-21A694231FBE}"/>
+          <p:cNvPr id="11" name="node-02">
+            <a:extLst xmlns:a="http://schemas.openxmlformats.org/drawingml/2006/main">
+              <a:ext uri="{FF2B5EF4-FFF2-40B4-BE49-F238E27FC236}">
+                <a16:creationId xmlns:a16="http://schemas.microsoft.com/office/drawing/2014/main" id="{AD4EA49F-F15B-4ECB-B6D1-3BC89B3D0E30}"/>
               </a:ext>
             </a:extLst>
           </p:cNvPr>
@@ -1682,10 +1611,10 @@
       </p:sp>
       <p:sp>
         <p:nvSpPr>
-          <p:cNvPr id="14" name="node-index-02">
-            <a:extLst xmlns:a="http://schemas.openxmlformats.org/drawingml/2006/main">
-              <a:ext uri="{FF2B5EF4-FFF2-40B4-BE49-F238E27FC236}">
-                <a16:creationId xmlns:a16="http://schemas.microsoft.com/office/drawing/2014/main" id="{0CC15675-7F25-41BD-ABCA-F059504FA33C}"/>
+          <p:cNvPr id="12" name="node-index-02">
+            <a:extLst xmlns:a="http://schemas.openxmlformats.org/drawingml/2006/main">
+              <a:ext uri="{FF2B5EF4-FFF2-40B4-BE49-F238E27FC236}">
+                <a16:creationId xmlns:a16="http://schemas.microsoft.com/office/drawing/2014/main" id="{40F87749-78CE-4402-8E94-0053D9E3B2C7}"/>
               </a:ext>
             </a:extLst>
           </p:cNvPr>
@@ -1732,10 +1661,10 @@
       </p:sp>
       <p:sp>
         <p:nvSpPr>
-          <p:cNvPr id="15" name="node-label-02">
-            <a:extLst xmlns:a="http://schemas.openxmlformats.org/drawingml/2006/main">
-              <a:ext uri="{FF2B5EF4-FFF2-40B4-BE49-F238E27FC236}">
-                <a16:creationId xmlns:a16="http://schemas.microsoft.com/office/drawing/2014/main" id="{F3E2DE2C-15FE-41F9-8C96-3ED6DC12AB92}"/>
+          <p:cNvPr id="13" name="node-label-02">
+            <a:extLst xmlns:a="http://schemas.openxmlformats.org/drawingml/2006/main">
+              <a:ext uri="{FF2B5EF4-FFF2-40B4-BE49-F238E27FC236}">
+                <a16:creationId xmlns:a16="http://schemas.microsoft.com/office/drawing/2014/main" id="{C30449E3-E0A5-4E54-8763-26ACD718BA18}"/>
               </a:ext>
             </a:extLst>
           </p:cNvPr>
@@ -1782,10 +1711,10 @@
       </p:sp>
       <p:sp>
         <p:nvSpPr>
-          <p:cNvPr id="16" name="node-03">
-            <a:extLst xmlns:a="http://schemas.openxmlformats.org/drawingml/2006/main">
-              <a:ext uri="{FF2B5EF4-FFF2-40B4-BE49-F238E27FC236}">
-                <a16:creationId xmlns:a16="http://schemas.microsoft.com/office/drawing/2014/main" id="{AEDE62EF-4AC2-478A-BB84-7541EA9EC4A3}"/>
+          <p:cNvPr id="14" name="node-03">
+            <a:extLst xmlns:a="http://schemas.openxmlformats.org/drawingml/2006/main">
+              <a:ext uri="{FF2B5EF4-FFF2-40B4-BE49-F238E27FC236}">
+                <a16:creationId xmlns:a16="http://schemas.microsoft.com/office/drawing/2014/main" id="{9A03B509-CDB7-4B96-B5E4-B72B2B6A20ED}"/>
               </a:ext>
             </a:extLst>
           </p:cNvPr>
@@ -1817,10 +1746,10 @@
       </p:sp>
       <p:sp>
         <p:nvSpPr>
-          <p:cNvPr id="17" name="node-index-03">
-            <a:extLst xmlns:a="http://schemas.openxmlformats.org/drawingml/2006/main">
-              <a:ext uri="{FF2B5EF4-FFF2-40B4-BE49-F238E27FC236}">
-                <a16:creationId xmlns:a16="http://schemas.microsoft.com/office/drawing/2014/main" id="{D2269E8C-EF3E-471E-8503-812197C21046}"/>
+          <p:cNvPr id="15" name="node-index-03">
+            <a:extLst xmlns:a="http://schemas.openxmlformats.org/drawingml/2006/main">
+              <a:ext uri="{FF2B5EF4-FFF2-40B4-BE49-F238E27FC236}">
+                <a16:creationId xmlns:a16="http://schemas.microsoft.com/office/drawing/2014/main" id="{37B7CE3A-5E9D-4ECD-8ED1-2607AF5D4E1C}"/>
               </a:ext>
             </a:extLst>
           </p:cNvPr>
@@ -1867,10 +1796,10 @@
       </p:sp>
       <p:sp>
         <p:nvSpPr>
-          <p:cNvPr id="18" name="node-label-03">
-            <a:extLst xmlns:a="http://schemas.openxmlformats.org/drawingml/2006/main">
-              <a:ext uri="{FF2B5EF4-FFF2-40B4-BE49-F238E27FC236}">
-                <a16:creationId xmlns:a16="http://schemas.microsoft.com/office/drawing/2014/main" id="{E2DA67F2-5019-4D47-84EB-2CD2ED51FC43}"/>
+          <p:cNvPr id="16" name="node-label-03">
+            <a:extLst xmlns:a="http://schemas.openxmlformats.org/drawingml/2006/main">
+              <a:ext uri="{FF2B5EF4-FFF2-40B4-BE49-F238E27FC236}">
+                <a16:creationId xmlns:a16="http://schemas.microsoft.com/office/drawing/2014/main" id="{5820B681-CB41-420A-8FC8-65868FDD862F}"/>
               </a:ext>
             </a:extLst>
           </p:cNvPr>
@@ -1917,10 +1846,10 @@
       </p:sp>
       <p:sp>
         <p:nvSpPr>
-          <p:cNvPr id="19" name="node-04">
-            <a:extLst xmlns:a="http://schemas.openxmlformats.org/drawingml/2006/main">
-              <a:ext uri="{FF2B5EF4-FFF2-40B4-BE49-F238E27FC236}">
-                <a16:creationId xmlns:a16="http://schemas.microsoft.com/office/drawing/2014/main" id="{245F16A0-0115-4059-82E8-CF09F11C32E5}"/>
+          <p:cNvPr id="17" name="node-04">
+            <a:extLst xmlns:a="http://schemas.openxmlformats.org/drawingml/2006/main">
+              <a:ext uri="{FF2B5EF4-FFF2-40B4-BE49-F238E27FC236}">
+                <a16:creationId xmlns:a16="http://schemas.microsoft.com/office/drawing/2014/main" id="{8DF42D0F-2338-4877-82C4-6402C0828962}"/>
               </a:ext>
             </a:extLst>
           </p:cNvPr>
@@ -1952,10 +1881,10 @@
       </p:sp>
       <p:sp>
         <p:nvSpPr>
-          <p:cNvPr id="20" name="node-index-04">
-            <a:extLst xmlns:a="http://schemas.openxmlformats.org/drawingml/2006/main">
-              <a:ext uri="{FF2B5EF4-FFF2-40B4-BE49-F238E27FC236}">
-                <a16:creationId xmlns:a16="http://schemas.microsoft.com/office/drawing/2014/main" id="{42AD4516-3E1A-4355-861A-4A3710E517C0}"/>
+          <p:cNvPr id="18" name="node-index-04">
+            <a:extLst xmlns:a="http://schemas.openxmlformats.org/drawingml/2006/main">
+              <a:ext uri="{FF2B5EF4-FFF2-40B4-BE49-F238E27FC236}">
+                <a16:creationId xmlns:a16="http://schemas.microsoft.com/office/drawing/2014/main" id="{AB673C04-013F-4D18-AA7C-F7137227AE21}"/>
               </a:ext>
             </a:extLst>
           </p:cNvPr>
@@ -2002,10 +1931,10 @@
       </p:sp>
       <p:sp>
         <p:nvSpPr>
-          <p:cNvPr id="21" name="node-label-04">
-            <a:extLst xmlns:a="http://schemas.openxmlformats.org/drawingml/2006/main">
-              <a:ext uri="{FF2B5EF4-FFF2-40B4-BE49-F238E27FC236}">
-                <a16:creationId xmlns:a16="http://schemas.microsoft.com/office/drawing/2014/main" id="{E2ECE7DA-EC31-48EB-B841-CD9BDCAFF636}"/>
+          <p:cNvPr id="19" name="node-label-04">
+            <a:extLst xmlns:a="http://schemas.openxmlformats.org/drawingml/2006/main">
+              <a:ext uri="{FF2B5EF4-FFF2-40B4-BE49-F238E27FC236}">
+                <a16:creationId xmlns:a16="http://schemas.microsoft.com/office/drawing/2014/main" id="{B6BDAF76-9614-47B1-9C0B-536E30759406}"/>
               </a:ext>
             </a:extLst>
           </p:cNvPr>
@@ -2033,45 +1962,130 @@
           <a:lstStyle xmlns:a="http://schemas.openxmlformats.org/drawingml/2006/main"/>
           <a:p xmlns:a="http://schemas.openxmlformats.org/drawingml/2006/main">
             <a:pPr algn="l">
-              <a:defRPr sz="1650" b="1">
+              <a:defRPr sz="1500" b="1">
                 <a:solidFill>
                   <a:srgbClr val="E8EDF7"/>
                 </a:solidFill>
               </a:defRPr>
             </a:pPr>
             <a:r>
-              <a:rPr sz="1650" b="1">
+              <a:rPr sz="1500" b="1">
                 <a:solidFill>
                   <a:srgbClr val="E8EDF7"/>
                 </a:solidFill>
               </a:rPr>
-              <a:t>Release reward</a:t>
-            </a:r>
-          </a:p>
-        </p:txBody>
-      </p:sp>
-      <p:sp>
-        <p:nvSpPr>
-          <p:cNvPr id="22" name="refund-node">
-            <a:extLst xmlns:a="http://schemas.openxmlformats.org/drawingml/2006/main">
-              <a:ext uri="{FF2B5EF4-FFF2-40B4-BE49-F238E27FC236}">
-                <a16:creationId xmlns:a16="http://schemas.microsoft.com/office/drawing/2014/main" id="{6F31E7C5-62EA-46D4-A71E-75F90FC9A8D7}"/>
-              </a:ext>
-            </a:extLst>
-          </p:cNvPr>
-          <p:cNvSpPr>
-            <a:spLocks xmlns:a="http://schemas.openxmlformats.org/drawingml/2006/main" noGrp="1"/>
-          </p:cNvSpPr>
-          <p:nvPr/>
-        </p:nvSpPr>
-        <p:spPr>
-          <a:xfrm xmlns:a="http://schemas.openxmlformats.org/drawingml/2006/main">
-            <a:off x="9601200" y="4076700"/>
-            <a:ext cx="1981200" cy="685800"/>
+              <a:t>Release to contributor</a:t>
+            </a:r>
+          </a:p>
+        </p:txBody>
+      </p:sp>
+      <p:sp>
+        <p:nvSpPr>
+          <p:cNvPr id="20" name="cancel-node">
+            <a:extLst xmlns:a="http://schemas.openxmlformats.org/drawingml/2006/main">
+              <a:ext uri="{FF2B5EF4-FFF2-40B4-BE49-F238E27FC236}">
+                <a16:creationId xmlns:a16="http://schemas.microsoft.com/office/drawing/2014/main" id="{F38B1896-C4D0-4A57-AAF2-241DFDFF3C94}"/>
+              </a:ext>
+            </a:extLst>
+          </p:cNvPr>
+          <p:cNvSpPr>
+            <a:spLocks xmlns:a="http://schemas.openxmlformats.org/drawingml/2006/main" noGrp="1"/>
+          </p:cNvSpPr>
+          <p:nvPr/>
+        </p:nvSpPr>
+        <p:spPr>
+          <a:xfrm xmlns:a="http://schemas.openxmlformats.org/drawingml/2006/main">
+            <a:off x="609600" y="4095750"/>
+            <a:ext cx="3238500" cy="533400"/>
           </a:xfrm>
           <a:prstGeom xmlns:a="http://schemas.openxmlformats.org/drawingml/2006/main" prst="roundRect">
             <a:avLst>
-              <a:gd name="adj" fmla="val 11111"/>
+              <a:gd name="adj" fmla="val 14286"/>
+            </a:avLst>
+          </a:prstGeom>
+          <a:solidFill xmlns:a="http://schemas.openxmlformats.org/drawingml/2006/main">
+            <a:srgbClr val="111726"/>
+          </a:solidFill>
+          <a:ln xmlns:a="http://schemas.openxmlformats.org/drawingml/2006/main" w="19050">
+            <a:solidFill>
+              <a:srgbClr val="9945FF"/>
+            </a:solidFill>
+            <a:prstDash val="solid"/>
+          </a:ln>
+        </p:spPr>
+      </p:sp>
+      <p:sp>
+        <p:nvSpPr>
+          <p:cNvPr id="21" name="cancel-label">
+            <a:extLst xmlns:a="http://schemas.openxmlformats.org/drawingml/2006/main">
+              <a:ext uri="{FF2B5EF4-FFF2-40B4-BE49-F238E27FC236}">
+                <a16:creationId xmlns:a16="http://schemas.microsoft.com/office/drawing/2014/main" id="{93BDCE29-9652-4DE9-9A4D-C260D92C7DE7}"/>
+              </a:ext>
+            </a:extLst>
+          </p:cNvPr>
+          <p:cNvSpPr>
+            <a:spLocks xmlns:a="http://schemas.openxmlformats.org/drawingml/2006/main" noGrp="1"/>
+          </p:cNvSpPr>
+          <p:nvPr/>
+        </p:nvSpPr>
+        <p:spPr>
+          <a:xfrm xmlns:a="http://schemas.openxmlformats.org/drawingml/2006/main">
+            <a:off x="800100" y="4267200"/>
+            <a:ext cx="2857500" cy="228600"/>
+          </a:xfrm>
+          <a:prstGeom xmlns:a="http://schemas.openxmlformats.org/drawingml/2006/main" prst="rect">
+            <a:avLst/>
+          </a:prstGeom>
+          <a:noFill xmlns:a="http://schemas.openxmlformats.org/drawingml/2006/main"/>
+          <a:ln xmlns:a="http://schemas.openxmlformats.org/drawingml/2006/main" w="0">
+            <a:noFill/>
+            <a:prstDash val="solid"/>
+          </a:ln>
+        </p:spPr>
+        <p:txBody>
+          <a:bodyPr xmlns:a="http://schemas.openxmlformats.org/drawingml/2006/main" anchor="t"/>
+          <a:lstStyle xmlns:a="http://schemas.openxmlformats.org/drawingml/2006/main"/>
+          <a:p xmlns:a="http://schemas.openxmlformats.org/drawingml/2006/main">
+            <a:pPr algn="l">
+              <a:defRPr sz="1350" b="1">
+                <a:solidFill>
+                  <a:srgbClr val="9945FF"/>
+                </a:solidFill>
+              </a:defRPr>
+            </a:pPr>
+            <a:r>
+              <a:rPr sz="1350" b="1">
+                <a:solidFill>
+                  <a:srgbClr val="9945FF"/>
+                </a:solidFill>
+              </a:rPr>
+              <a:t>Before funding → sponsor cancels</a:t>
+            </a:r>
+          </a:p>
+        </p:txBody>
+      </p:sp>
+      <p:sp>
+        <p:nvSpPr>
+          <p:cNvPr id="22" name="refund-node">
+            <a:extLst xmlns:a="http://schemas.openxmlformats.org/drawingml/2006/main">
+              <a:ext uri="{FF2B5EF4-FFF2-40B4-BE49-F238E27FC236}">
+                <a16:creationId xmlns:a16="http://schemas.microsoft.com/office/drawing/2014/main" id="{8EA24E4D-6E4D-4366-A3AE-A6777F18EFCC}"/>
+              </a:ext>
+            </a:extLst>
+          </p:cNvPr>
+          <p:cNvSpPr>
+            <a:spLocks xmlns:a="http://schemas.openxmlformats.org/drawingml/2006/main" noGrp="1"/>
+          </p:cNvSpPr>
+          <p:nvPr/>
+        </p:nvSpPr>
+        <p:spPr>
+          <a:xfrm xmlns:a="http://schemas.openxmlformats.org/drawingml/2006/main">
+            <a:off x="8343900" y="4095750"/>
+            <a:ext cx="3238500" cy="533400"/>
+          </a:xfrm>
+          <a:prstGeom xmlns:a="http://schemas.openxmlformats.org/drawingml/2006/main" prst="roundRect">
+            <a:avLst>
+              <a:gd name="adj" fmla="val 14286"/>
             </a:avLst>
           </a:prstGeom>
           <a:solidFill xmlns:a="http://schemas.openxmlformats.org/drawingml/2006/main">
@@ -2090,19 +2104,19 @@
           <p:cNvPr id="23" name="refund-label">
             <a:extLst xmlns:a="http://schemas.openxmlformats.org/drawingml/2006/main">
               <a:ext uri="{FF2B5EF4-FFF2-40B4-BE49-F238E27FC236}">
-                <a16:creationId xmlns:a16="http://schemas.microsoft.com/office/drawing/2014/main" id="{BB03A810-DCD3-46D0-8CC4-E1520865EB01}"/>
-              </a:ext>
-            </a:extLst>
-          </p:cNvPr>
-          <p:cNvSpPr>
-            <a:spLocks xmlns:a="http://schemas.openxmlformats.org/drawingml/2006/main" noGrp="1"/>
-          </p:cNvSpPr>
-          <p:nvPr/>
-        </p:nvSpPr>
-        <p:spPr>
-          <a:xfrm xmlns:a="http://schemas.openxmlformats.org/drawingml/2006/main">
-            <a:off x="9772650" y="4286250"/>
-            <a:ext cx="1657350" cy="266700"/>
+                <a16:creationId xmlns:a16="http://schemas.microsoft.com/office/drawing/2014/main" id="{B4F2C5A6-D92E-436A-B3CA-D858D14F9BE0}"/>
+              </a:ext>
+            </a:extLst>
+          </p:cNvPr>
+          <p:cNvSpPr>
+            <a:spLocks xmlns:a="http://schemas.openxmlformats.org/drawingml/2006/main" noGrp="1"/>
+          </p:cNvSpPr>
+          <p:nvPr/>
+        </p:nvSpPr>
+        <p:spPr>
+          <a:xfrm xmlns:a="http://schemas.openxmlformats.org/drawingml/2006/main">
+            <a:off x="8534400" y="4267200"/>
+            <a:ext cx="2857500" cy="228600"/>
           </a:xfrm>
           <a:prstGeom xmlns:a="http://schemas.openxmlformats.org/drawingml/2006/main" prst="rect">
             <a:avLst/>
@@ -2118,19 +2132,19 @@
           <a:lstStyle xmlns:a="http://schemas.openxmlformats.org/drawingml/2006/main"/>
           <a:p xmlns:a="http://schemas.openxmlformats.org/drawingml/2006/main">
             <a:pPr algn="l">
-              <a:defRPr sz="1425" b="1">
+              <a:defRPr sz="1350" b="1">
                 <a:solidFill>
                   <a:srgbClr val="F5A524"/>
                 </a:solidFill>
               </a:defRPr>
             </a:pPr>
             <a:r>
-              <a:rPr sz="1425" b="1">
+              <a:rPr sz="1350" b="1">
                 <a:solidFill>
                   <a:srgbClr val="F5A524"/>
                 </a:solidFill>
               </a:rPr>
-              <a:t>Expiry → sponsor refund</a:t>
+              <a:t>At expiry → sponsor refund</a:t>
             </a:r>
           </a:p>
         </p:txBody>
@@ -2140,7 +2154,7 @@
           <p:cNvPr id="24" name="why-title">
             <a:extLst xmlns:a="http://schemas.openxmlformats.org/drawingml/2006/main">
               <a:ext uri="{FF2B5EF4-FFF2-40B4-BE49-F238E27FC236}">
-                <a16:creationId xmlns:a16="http://schemas.microsoft.com/office/drawing/2014/main" id="{0FD993C7-EEC1-4641-93AB-77C4AFFFA14E}"/>
+                <a16:creationId xmlns:a16="http://schemas.microsoft.com/office/drawing/2014/main" id="{788B6377-73D7-4B5F-B512-7A4C5A64790C}"/>
               </a:ext>
             </a:extLst>
           </p:cNvPr>
@@ -2190,7 +2204,7 @@
           <p:cNvPr id="25" name="why-body">
             <a:extLst xmlns:a="http://schemas.openxmlformats.org/drawingml/2006/main">
               <a:ext uri="{FF2B5EF4-FFF2-40B4-BE49-F238E27FC236}">
-                <a16:creationId xmlns:a16="http://schemas.microsoft.com/office/drawing/2014/main" id="{56FD867D-5D54-4331-BCDF-9E794286639B}"/>
+                <a16:creationId xmlns:a16="http://schemas.microsoft.com/office/drawing/2014/main" id="{6635B33D-9617-4749-8DE8-575635813F34}"/>
               </a:ext>
             </a:extLst>
           </p:cNvPr>
@@ -2240,7 +2254,7 @@
           <p:cNvPr id="26" name="boundary-bar">
             <a:extLst xmlns:a="http://schemas.openxmlformats.org/drawingml/2006/main">
               <a:ext uri="{FF2B5EF4-FFF2-40B4-BE49-F238E27FC236}">
-                <a16:creationId xmlns:a16="http://schemas.microsoft.com/office/drawing/2014/main" id="{52ED91F1-8226-4CE0-B355-DD8880E11135}"/>
+                <a16:creationId xmlns:a16="http://schemas.microsoft.com/office/drawing/2014/main" id="{C6CC174A-B100-48C1-8BEC-FA43675D1929}"/>
               </a:ext>
             </a:extLst>
           </p:cNvPr>
@@ -2275,7 +2289,7 @@
           <p:cNvPr id="27" name="boundary-title">
             <a:extLst xmlns:a="http://schemas.openxmlformats.org/drawingml/2006/main">
               <a:ext uri="{FF2B5EF4-FFF2-40B4-BE49-F238E27FC236}">
-                <a16:creationId xmlns:a16="http://schemas.microsoft.com/office/drawing/2014/main" id="{DF1B79A9-0CB6-4896-BAF0-5CD10ED6EAEF}"/>
+                <a16:creationId xmlns:a16="http://schemas.microsoft.com/office/drawing/2014/main" id="{7C1E8A8D-AC59-448F-8C63-E08ABAD58F61}"/>
               </a:ext>
             </a:extLst>
           </p:cNvPr>
@@ -2325,7 +2339,7 @@
           <p:cNvPr id="28" name="boundary-body">
             <a:extLst xmlns:a="http://schemas.openxmlformats.org/drawingml/2006/main">
               <a:ext uri="{FF2B5EF4-FFF2-40B4-BE49-F238E27FC236}">
-                <a16:creationId xmlns:a16="http://schemas.microsoft.com/office/drawing/2014/main" id="{374B06DC-382B-42CB-A366-DCF72428919A}"/>
+                <a16:creationId xmlns:a16="http://schemas.microsoft.com/office/drawing/2014/main" id="{6B770A56-4BF1-4DCF-BA4F-9C6C64C1BD8E}"/>
               </a:ext>
             </a:extLst>
           </p:cNvPr>
@@ -2375,7 +2389,7 @@
           <p:cNvPr id="29" name="footer-rule-1">
             <a:extLst xmlns:a="http://schemas.openxmlformats.org/drawingml/2006/main">
               <a:ext uri="{FF2B5EF4-FFF2-40B4-BE49-F238E27FC236}">
-                <a16:creationId xmlns:a16="http://schemas.microsoft.com/office/drawing/2014/main" id="{AD112649-F8F6-447F-915A-981F154C2877}"/>
+                <a16:creationId xmlns:a16="http://schemas.microsoft.com/office/drawing/2014/main" id="{3C286985-ACDA-43D8-898B-E9B4ACBDE347}"/>
               </a:ext>
             </a:extLst>
           </p:cNvPr>
@@ -2408,7 +2422,7 @@
           <p:cNvPr id="30" name="footer-left-1">
             <a:extLst xmlns:a="http://schemas.openxmlformats.org/drawingml/2006/main">
               <a:ext uri="{FF2B5EF4-FFF2-40B4-BE49-F238E27FC236}">
-                <a16:creationId xmlns:a16="http://schemas.microsoft.com/office/drawing/2014/main" id="{67DB4730-5D84-44C1-962B-1DBCB7FADC9D}"/>
+                <a16:creationId xmlns:a16="http://schemas.microsoft.com/office/drawing/2014/main" id="{3E2C8DF4-0086-4BBB-8DE7-370393BDE7B5}"/>
               </a:ext>
             </a:extLst>
           </p:cNvPr>
@@ -2458,7 +2472,7 @@
           <p:cNvPr id="31" name="footer-page-1">
             <a:extLst xmlns:a="http://schemas.openxmlformats.org/drawingml/2006/main">
               <a:ext uri="{FF2B5EF4-FFF2-40B4-BE49-F238E27FC236}">
-                <a16:creationId xmlns:a16="http://schemas.microsoft.com/office/drawing/2014/main" id="{399FAE49-B2BF-45E0-8E4A-5EE8457D86A5}"/>
+                <a16:creationId xmlns:a16="http://schemas.microsoft.com/office/drawing/2014/main" id="{42BDCEF5-58B1-420A-8E62-D8DBFA8BFDA5}"/>
               </a:ext>
             </a:extLst>
           </p:cNvPr>
@@ -2506,7 +2520,7 @@
     </p:spTree>
     <p:extLst>
       <p:ext uri="{BB962C8B-B14F-4D97-AF65-F5344CB8AC3E}">
-        <p14:creationId xmlns:p14="http://schemas.microsoft.com/office/powerpoint/2010/main" val="239021888"/>
+        <p14:creationId xmlns:p14="http://schemas.microsoft.com/office/powerpoint/2010/main" val="742261433"/>
       </p:ext>
     </p:extLst>
   </p:cSld>
@@ -2534,10 +2548,10 @@
       </p:grpSpPr>
       <p:sp>
         <p:nvSpPr>
-          <p:cNvPr id="23" name="project-label-2">
-            <a:extLst xmlns:a="http://schemas.openxmlformats.org/drawingml/2006/main">
-              <a:ext uri="{FF2B5EF4-FFF2-40B4-BE49-F238E27FC236}">
-                <a16:creationId xmlns:a16="http://schemas.microsoft.com/office/drawing/2014/main" id="{06033003-230B-4228-B515-8F50303F8785}"/>
+          <p:cNvPr id="22" name="project-label-2">
+            <a:extLst xmlns:a="http://schemas.openxmlformats.org/drawingml/2006/main">
+              <a:ext uri="{FF2B5EF4-FFF2-40B4-BE49-F238E27FC236}">
+                <a16:creationId xmlns:a16="http://schemas.microsoft.com/office/drawing/2014/main" id="{95E7F3C5-C172-4B82-B409-541F2A0AE255}"/>
               </a:ext>
             </a:extLst>
           </p:cNvPr>
@@ -2587,7 +2601,7 @@
           <p:cNvPr id="2" name="headline-2">
             <a:extLst xmlns:a="http://schemas.openxmlformats.org/drawingml/2006/main">
               <a:ext uri="{FF2B5EF4-FFF2-40B4-BE49-F238E27FC236}">
-                <a16:creationId xmlns:a16="http://schemas.microsoft.com/office/drawing/2014/main" id="{CC772BCD-51E1-4077-80F5-B2A6387E0F6C}"/>
+                <a16:creationId xmlns:a16="http://schemas.microsoft.com/office/drawing/2014/main" id="{CB5420BF-B7BC-4D35-883B-2B9A563E2916}"/>
               </a:ext>
             </a:extLst>
           </p:cNvPr>
@@ -2637,7 +2651,7 @@
           <p:cNvPr id="3" name="proof-kicker">
             <a:extLst xmlns:a="http://schemas.openxmlformats.org/drawingml/2006/main">
               <a:ext uri="{FF2B5EF4-FFF2-40B4-BE49-F238E27FC236}">
-                <a16:creationId xmlns:a16="http://schemas.microsoft.com/office/drawing/2014/main" id="{5DEBF3B5-6326-4B0A-B794-AE0D7596D32F}"/>
+                <a16:creationId xmlns:a16="http://schemas.microsoft.com/office/drawing/2014/main" id="{3A75FD00-90C2-4DDA-9CDE-5F04FC7EB678}"/>
               </a:ext>
             </a:extLst>
           </p:cNvPr>
@@ -2687,7 +2701,7 @@
           <p:cNvPr id="4" name="metric-value-12">
             <a:extLst xmlns:a="http://schemas.openxmlformats.org/drawingml/2006/main">
               <a:ext uri="{FF2B5EF4-FFF2-40B4-BE49-F238E27FC236}">
-                <a16:creationId xmlns:a16="http://schemas.microsoft.com/office/drawing/2014/main" id="{8D0DF01A-F646-42E6-842D-B6914AFA7AC3}"/>
+                <a16:creationId xmlns:a16="http://schemas.microsoft.com/office/drawing/2014/main" id="{D88E7344-B628-4F0C-BA45-BC49F24B7FCD}"/>
               </a:ext>
             </a:extLst>
           </p:cNvPr>
@@ -2737,7 +2751,7 @@
           <p:cNvPr id="5" name="metric-label-12">
             <a:extLst xmlns:a="http://schemas.openxmlformats.org/drawingml/2006/main">
               <a:ext uri="{FF2B5EF4-FFF2-40B4-BE49-F238E27FC236}">
-                <a16:creationId xmlns:a16="http://schemas.microsoft.com/office/drawing/2014/main" id="{242E7A46-5739-4015-A250-3C9AE81FA2BC}"/>
+                <a16:creationId xmlns:a16="http://schemas.microsoft.com/office/drawing/2014/main" id="{7B9D96F4-A20D-4023-B1B6-9330FA827101}"/>
               </a:ext>
             </a:extLst>
           </p:cNvPr>
@@ -2787,7 +2801,7 @@
           <p:cNvPr id="6" name="metric-value-3">
             <a:extLst xmlns:a="http://schemas.openxmlformats.org/drawingml/2006/main">
               <a:ext uri="{FF2B5EF4-FFF2-40B4-BE49-F238E27FC236}">
-                <a16:creationId xmlns:a16="http://schemas.microsoft.com/office/drawing/2014/main" id="{5557B2F5-E141-4C99-8C9E-85BA956F9C72}"/>
+                <a16:creationId xmlns:a16="http://schemas.microsoft.com/office/drawing/2014/main" id="{3B1BA513-449C-4446-888E-0A889900871D}"/>
               </a:ext>
             </a:extLst>
           </p:cNvPr>
@@ -2837,7 +2851,7 @@
           <p:cNvPr id="7" name="metric-label-3">
             <a:extLst xmlns:a="http://schemas.openxmlformats.org/drawingml/2006/main">
               <a:ext uri="{FF2B5EF4-FFF2-40B4-BE49-F238E27FC236}">
-                <a16:creationId xmlns:a16="http://schemas.microsoft.com/office/drawing/2014/main" id="{7E8C9DC9-A956-404E-BDC9-DC54E7FAD055}"/>
+                <a16:creationId xmlns:a16="http://schemas.microsoft.com/office/drawing/2014/main" id="{58F8E998-4B1F-47EC-A119-5FD0D696128D}"/>
               </a:ext>
             </a:extLst>
           </p:cNvPr>
@@ -2887,7 +2901,7 @@
           <p:cNvPr id="8" name="metric-value-1">
             <a:extLst xmlns:a="http://schemas.openxmlformats.org/drawingml/2006/main">
               <a:ext uri="{FF2B5EF4-FFF2-40B4-BE49-F238E27FC236}">
-                <a16:creationId xmlns:a16="http://schemas.microsoft.com/office/drawing/2014/main" id="{C55B2A99-DABB-4776-87F7-FDB9C3EFD2D4}"/>
+                <a16:creationId xmlns:a16="http://schemas.microsoft.com/office/drawing/2014/main" id="{F8EC042E-0639-443C-9391-A3DC17C994F2}"/>
               </a:ext>
             </a:extLst>
           </p:cNvPr>
@@ -2937,7 +2951,7 @@
           <p:cNvPr id="9" name="metric-label-1">
             <a:extLst xmlns:a="http://schemas.openxmlformats.org/drawingml/2006/main">
               <a:ext uri="{FF2B5EF4-FFF2-40B4-BE49-F238E27FC236}">
-                <a16:creationId xmlns:a16="http://schemas.microsoft.com/office/drawing/2014/main" id="{2E7182AA-B038-46FD-8C51-932307B540AE}"/>
+                <a16:creationId xmlns:a16="http://schemas.microsoft.com/office/drawing/2014/main" id="{7C2081B9-CDE8-463C-AE5A-C40B5934E3CA}"/>
               </a:ext>
             </a:extLst>
           </p:cNvPr>
@@ -2987,7 +3001,7 @@
           <p:cNvPr id="10" name="accounting-surface">
             <a:extLst xmlns:a="http://schemas.openxmlformats.org/drawingml/2006/main">
               <a:ext uri="{FF2B5EF4-FFF2-40B4-BE49-F238E27FC236}">
-                <a16:creationId xmlns:a16="http://schemas.microsoft.com/office/drawing/2014/main" id="{5BD20EE5-0774-4AA4-821F-18EE0AD29EBA}"/>
+                <a16:creationId xmlns:a16="http://schemas.microsoft.com/office/drawing/2014/main" id="{B7CC9D78-DF37-4F3E-A76D-E708D55D058B}"/>
               </a:ext>
             </a:extLst>
           </p:cNvPr>
@@ -3022,7 +3036,7 @@
           <p:cNvPr id="11" name="accounting-title">
             <a:extLst xmlns:a="http://schemas.openxmlformats.org/drawingml/2006/main">
               <a:ext uri="{FF2B5EF4-FFF2-40B4-BE49-F238E27FC236}">
-                <a16:creationId xmlns:a16="http://schemas.microsoft.com/office/drawing/2014/main" id="{4E5A52CC-7322-415C-8811-30D40FE1CF9F}"/>
+                <a16:creationId xmlns:a16="http://schemas.microsoft.com/office/drawing/2014/main" id="{50084876-9F40-4DC5-9BC8-B4E4DA1A56B6}"/>
               </a:ext>
             </a:extLst>
           </p:cNvPr>
@@ -3072,7 +3086,7 @@
           <p:cNvPr id="12" name="accounting-equation">
             <a:extLst xmlns:a="http://schemas.openxmlformats.org/drawingml/2006/main">
               <a:ext uri="{FF2B5EF4-FFF2-40B4-BE49-F238E27FC236}">
-                <a16:creationId xmlns:a16="http://schemas.microsoft.com/office/drawing/2014/main" id="{B0DECF24-04CB-42A9-B433-CC127FD3FA7F}"/>
+                <a16:creationId xmlns:a16="http://schemas.microsoft.com/office/drawing/2014/main" id="{856505D9-F6A3-4ECD-83D1-77776A265EF9}"/>
               </a:ext>
             </a:extLst>
           </p:cNvPr>
@@ -3122,7 +3136,7 @@
           <p:cNvPr id="13" name="vault-note">
             <a:extLst xmlns:a="http://schemas.openxmlformats.org/drawingml/2006/main">
               <a:ext uri="{FF2B5EF4-FFF2-40B4-BE49-F238E27FC236}">
-                <a16:creationId xmlns:a16="http://schemas.microsoft.com/office/drawing/2014/main" id="{6AD6B99B-81B4-43F9-B183-E9BFFEE18787}"/>
+                <a16:creationId xmlns:a16="http://schemas.microsoft.com/office/drawing/2014/main" id="{3C1FBA59-77F6-4574-B21F-771CEF5F3FF0}"/>
               </a:ext>
             </a:extLst>
           </p:cNvPr>
@@ -3172,7 +3186,7 @@
           <p:cNvPr id="14" name="direction-accent">
             <a:extLst xmlns:a="http://schemas.openxmlformats.org/drawingml/2006/main">
               <a:ext uri="{FF2B5EF4-FFF2-40B4-BE49-F238E27FC236}">
-                <a16:creationId xmlns:a16="http://schemas.microsoft.com/office/drawing/2014/main" id="{59C5BA3D-05B7-4634-B2C2-411752A5E825}"/>
+                <a16:creationId xmlns:a16="http://schemas.microsoft.com/office/drawing/2014/main" id="{C236F8FF-37A7-4D42-ABFF-3F73E1FB3AF4}"/>
               </a:ext>
             </a:extLst>
           </p:cNvPr>
@@ -3205,7 +3219,7 @@
           <p:cNvPr id="15" name="direction-title">
             <a:extLst xmlns:a="http://schemas.openxmlformats.org/drawingml/2006/main">
               <a:ext uri="{FF2B5EF4-FFF2-40B4-BE49-F238E27FC236}">
-                <a16:creationId xmlns:a16="http://schemas.microsoft.com/office/drawing/2014/main" id="{32C7E521-0073-4192-8388-EB8B7C7D6C9F}"/>
+                <a16:creationId xmlns:a16="http://schemas.microsoft.com/office/drawing/2014/main" id="{E5FEA725-C593-4E76-9B84-D60C355B0745}"/>
               </a:ext>
             </a:extLst>
           </p:cNvPr>
@@ -3255,7 +3269,7 @@
           <p:cNvPr id="16" name="direction-body">
             <a:extLst xmlns:a="http://schemas.openxmlformats.org/drawingml/2006/main">
               <a:ext uri="{FF2B5EF4-FFF2-40B4-BE49-F238E27FC236}">
-                <a16:creationId xmlns:a16="http://schemas.microsoft.com/office/drawing/2014/main" id="{63596143-298D-4157-B685-C10442659915}"/>
+                <a16:creationId xmlns:a16="http://schemas.microsoft.com/office/drawing/2014/main" id="{D6B6D4A7-2430-4589-84EE-557DB0F9F42B}"/>
               </a:ext>
             </a:extLst>
           </p:cNvPr>
@@ -3305,7 +3319,7 @@
           <p:cNvPr id="17" name="limits-title">
             <a:extLst xmlns:a="http://schemas.openxmlformats.org/drawingml/2006/main">
               <a:ext uri="{FF2B5EF4-FFF2-40B4-BE49-F238E27FC236}">
-                <a16:creationId xmlns:a16="http://schemas.microsoft.com/office/drawing/2014/main" id="{FF427A50-9B49-4566-8E0B-B0DE73D7EE3D}"/>
+                <a16:creationId xmlns:a16="http://schemas.microsoft.com/office/drawing/2014/main" id="{58F1BDBF-CE79-40D0-9F27-C538A35F1DCB}"/>
               </a:ext>
             </a:extLst>
           </p:cNvPr>
@@ -3355,7 +3369,7 @@
           <p:cNvPr id="18" name="limits-body">
             <a:extLst xmlns:a="http://schemas.openxmlformats.org/drawingml/2006/main">
               <a:ext uri="{FF2B5EF4-FFF2-40B4-BE49-F238E27FC236}">
-                <a16:creationId xmlns:a16="http://schemas.microsoft.com/office/drawing/2014/main" id="{83569310-5509-4FC3-8488-ACBFA5E963A8}"/>
+                <a16:creationId xmlns:a16="http://schemas.microsoft.com/office/drawing/2014/main" id="{EB421E23-9C47-475A-B501-4E1250A5E4C0}"/>
               </a:ext>
             </a:extLst>
           </p:cNvPr>
@@ -3402,60 +3416,10 @@
       </p:sp>
       <p:sp>
         <p:nvSpPr>
-          <p:cNvPr id="19" name="local-placeholder">
-            <a:extLst xmlns:a="http://schemas.openxmlformats.org/drawingml/2006/main">
-              <a:ext uri="{FF2B5EF4-FFF2-40B4-BE49-F238E27FC236}">
-                <a16:creationId xmlns:a16="http://schemas.microsoft.com/office/drawing/2014/main" id="{225FD705-AEFB-4E75-9857-AFC8376DEE9C}"/>
-              </a:ext>
-            </a:extLst>
-          </p:cNvPr>
-          <p:cNvSpPr>
-            <a:spLocks xmlns:a="http://schemas.openxmlformats.org/drawingml/2006/main" noGrp="1"/>
-          </p:cNvSpPr>
-          <p:nvPr/>
-        </p:nvSpPr>
-        <p:spPr>
-          <a:xfrm xmlns:a="http://schemas.openxmlformats.org/drawingml/2006/main">
-            <a:off x="7105650" y="5476875"/>
-            <a:ext cx="4286250" cy="266700"/>
-          </a:xfrm>
-          <a:prstGeom xmlns:a="http://schemas.openxmlformats.org/drawingml/2006/main" prst="rect">
-            <a:avLst/>
-          </a:prstGeom>
-          <a:noFill xmlns:a="http://schemas.openxmlformats.org/drawingml/2006/main"/>
-          <a:ln xmlns:a="http://schemas.openxmlformats.org/drawingml/2006/main" w="0">
-            <a:noFill/>
-            <a:prstDash val="solid"/>
-          </a:ln>
-        </p:spPr>
-        <p:txBody>
-          <a:bodyPr xmlns:a="http://schemas.openxmlformats.org/drawingml/2006/main" anchor="t"/>
-          <a:lstStyle xmlns:a="http://schemas.openxmlformats.org/drawingml/2006/main"/>
-          <a:p xmlns:a="http://schemas.openxmlformats.org/drawingml/2006/main">
-            <a:pPr algn="l">
-              <a:defRPr sz="1200" b="1">
-                <a:solidFill>
-                  <a:srgbClr val="9AA7C2"/>
-                </a:solidFill>
-              </a:defRPr>
-            </a:pPr>
-            <a:r>
-              <a:rPr sz="1200" b="1">
-                <a:solidFill>
-                  <a:srgbClr val="9AA7C2"/>
-                </a:solidFill>
-              </a:rPr>
-              <a:t>Public reviewer URL added after publication authorization</a:t>
-            </a:r>
-          </a:p>
-        </p:txBody>
-      </p:sp>
-      <p:sp>
-        <p:nvSpPr>
-          <p:cNvPr id="20" name="footer-rule-2">
-            <a:extLst xmlns:a="http://schemas.openxmlformats.org/drawingml/2006/main">
-              <a:ext uri="{FF2B5EF4-FFF2-40B4-BE49-F238E27FC236}">
-                <a16:creationId xmlns:a16="http://schemas.microsoft.com/office/drawing/2014/main" id="{9E1D5DC0-3492-4328-B973-74A3C5DBD75C}"/>
+          <p:cNvPr id="19" name="footer-rule-2">
+            <a:extLst xmlns:a="http://schemas.openxmlformats.org/drawingml/2006/main">
+              <a:ext uri="{FF2B5EF4-FFF2-40B4-BE49-F238E27FC236}">
+                <a16:creationId xmlns:a16="http://schemas.microsoft.com/office/drawing/2014/main" id="{6D012F8D-E531-469D-97EF-07A3F201CFE2}"/>
               </a:ext>
             </a:extLst>
           </p:cNvPr>
@@ -3485,10 +3449,10 @@
       </p:sp>
       <p:sp>
         <p:nvSpPr>
-          <p:cNvPr id="21" name="footer-left-2">
-            <a:extLst xmlns:a="http://schemas.openxmlformats.org/drawingml/2006/main">
-              <a:ext uri="{FF2B5EF4-FFF2-40B4-BE49-F238E27FC236}">
-                <a16:creationId xmlns:a16="http://schemas.microsoft.com/office/drawing/2014/main" id="{A9FE0B21-46C8-49DE-AC55-A282D6FC560E}"/>
+          <p:cNvPr id="20" name="footer-left-2">
+            <a:extLst xmlns:a="http://schemas.openxmlformats.org/drawingml/2006/main">
+              <a:ext uri="{FF2B5EF4-FFF2-40B4-BE49-F238E27FC236}">
+                <a16:creationId xmlns:a16="http://schemas.microsoft.com/office/drawing/2014/main" id="{C0487E14-B191-4C1D-A1FA-AAC13505157A}"/>
               </a:ext>
             </a:extLst>
           </p:cNvPr>
@@ -3535,10 +3499,10 @@
       </p:sp>
       <p:sp>
         <p:nvSpPr>
-          <p:cNvPr id="22" name="footer-page-2">
-            <a:extLst xmlns:a="http://schemas.openxmlformats.org/drawingml/2006/main">
-              <a:ext uri="{FF2B5EF4-FFF2-40B4-BE49-F238E27FC236}">
-                <a16:creationId xmlns:a16="http://schemas.microsoft.com/office/drawing/2014/main" id="{9D1E6E9B-1FE1-4F34-B6BF-E741FC87B146}"/>
+          <p:cNvPr id="21" name="footer-page-2">
+            <a:extLst xmlns:a="http://schemas.openxmlformats.org/drawingml/2006/main">
+              <a:ext uri="{FF2B5EF4-FFF2-40B4-BE49-F238E27FC236}">
+                <a16:creationId xmlns:a16="http://schemas.microsoft.com/office/drawing/2014/main" id="{7CA27F5D-0D34-40C3-AC5C-7374BE47C4E5}"/>
               </a:ext>
             </a:extLst>
           </p:cNvPr>
@@ -3586,7 +3550,7 @@
     </p:spTree>
     <p:extLst>
       <p:ext uri="{BB962C8B-B14F-4D97-AF65-F5344CB8AC3E}">
-        <p14:creationId xmlns:p14="http://schemas.microsoft.com/office/powerpoint/2010/main" val="839619808"/>
+        <p14:creationId xmlns:p14="http://schemas.microsoft.com/office/powerpoint/2010/main" val="995297735"/>
       </p:ext>
     </p:extLst>
   </p:cSld>

</xml_diff>